<commit_message>
feat: 3 slides de arquitectura para workshop AYCO 8 Mayo
- Slide 1: Arquitectura General (3 casos de uso sobre infraestructura unificada)
- Slide 2: Pipeline Risk Scoring + Data Platform (ERP → DWS → dashboards)
- Slide 3: Pipeline Contract AI + Dify (OCR → DeepSeek → chatbot)
- Dark theme (navy #1A1A2E), paleta Huawei Cloud, solo arquitecturas
- PPTX + PDF incluidos
</commit_message>
<xml_diff>
--- a/docs/slides-arquitectura.pptx
+++ b/docs/slides-arquitectura.pptx
@@ -1119,7 +1119,7 @@
             <a:r>
               <a:rPr lang="en-US" sz="900" dirty="0">
                 <a:solidFill>
-                  <a:srgbClr val="8A8FA3"/>
+                  <a:srgbClr val="B0B0B0"/>
                 </a:solidFill>
                 <a:latin typeface="Calibri" pitchFamily="34" charset="0"/>
                 <a:ea typeface="Calibri" pitchFamily="34" charset="-122"/>
@@ -3556,7 +3556,7 @@
             <a:r>
               <a:rPr lang="en-US" sz="700" dirty="0">
                 <a:solidFill>
-                  <a:srgbClr val="8A8FA3"/>
+                  <a:srgbClr val="B0B0B0"/>
                 </a:solidFill>
                 <a:latin typeface="Calibri" pitchFamily="34" charset="0"/>
                 <a:ea typeface="Calibri" pitchFamily="34" charset="-122"/>
@@ -3634,7 +3634,7 @@
             <a:r>
               <a:rPr lang="en-US" sz="700" dirty="0">
                 <a:solidFill>
-                  <a:srgbClr val="8A8FA3"/>
+                  <a:srgbClr val="B0B0B0"/>
                 </a:solidFill>
                 <a:latin typeface="Calibri" pitchFamily="34" charset="0"/>
                 <a:ea typeface="Calibri" pitchFamily="34" charset="-122"/>
@@ -3712,7 +3712,7 @@
             <a:r>
               <a:rPr lang="en-US" sz="700" dirty="0">
                 <a:solidFill>
-                  <a:srgbClr val="8A8FA3"/>
+                  <a:srgbClr val="B0B0B0"/>
                 </a:solidFill>
                 <a:latin typeface="Calibri" pitchFamily="34" charset="0"/>
                 <a:ea typeface="Calibri" pitchFamily="34" charset="-122"/>
@@ -3751,7 +3751,7 @@
             <a:r>
               <a:rPr lang="en-US" sz="700" dirty="0">
                 <a:solidFill>
-                  <a:srgbClr val="8A8FA3"/>
+                  <a:srgbClr val="B0B0B0"/>
                 </a:solidFill>
                 <a:latin typeface="Calibri" pitchFamily="34" charset="0"/>
                 <a:ea typeface="Calibri" pitchFamily="34" charset="-122"/>
@@ -3861,7 +3861,7 @@
             <a:r>
               <a:rPr lang="en-US" sz="900" dirty="0">
                 <a:solidFill>
-                  <a:srgbClr val="8A8FA3"/>
+                  <a:srgbClr val="B0B0B0"/>
                 </a:solidFill>
                 <a:latin typeface="Calibri" pitchFamily="34" charset="0"/>
                 <a:ea typeface="Calibri" pitchFamily="34" charset="-122"/>
@@ -4914,7 +4914,7 @@
             <a:r>
               <a:rPr lang="en-US" sz="800" dirty="0">
                 <a:solidFill>
-                  <a:srgbClr val="8A8FA3"/>
+                  <a:srgbClr val="B0B0B0"/>
                 </a:solidFill>
                 <a:latin typeface="Calibri" pitchFamily="34" charset="0"/>
                 <a:ea typeface="Calibri" pitchFamily="34" charset="-122"/>
@@ -4931,7 +4931,7 @@
             <a:r>
               <a:rPr lang="en-US" sz="800" dirty="0">
                 <a:solidFill>
-                  <a:srgbClr val="8A8FA3"/>
+                  <a:srgbClr val="B0B0B0"/>
                 </a:solidFill>
                 <a:latin typeface="Calibri" pitchFamily="34" charset="0"/>
                 <a:ea typeface="Calibri" pitchFamily="34" charset="-122"/>
@@ -5009,7 +5009,7 @@
             <a:r>
               <a:rPr lang="en-US" sz="800" dirty="0">
                 <a:solidFill>
-                  <a:srgbClr val="8A8FA3"/>
+                  <a:srgbClr val="B0B0B0"/>
                 </a:solidFill>
                 <a:latin typeface="Calibri" pitchFamily="34" charset="0"/>
                 <a:ea typeface="Calibri" pitchFamily="34" charset="-122"/>
@@ -5026,7 +5026,7 @@
             <a:r>
               <a:rPr lang="en-US" sz="800" dirty="0">
                 <a:solidFill>
-                  <a:srgbClr val="8A8FA3"/>
+                  <a:srgbClr val="B0B0B0"/>
                 </a:solidFill>
                 <a:latin typeface="Calibri" pitchFamily="34" charset="0"/>
                 <a:ea typeface="Calibri" pitchFamily="34" charset="-122"/>
@@ -5104,7 +5104,7 @@
             <a:r>
               <a:rPr lang="en-US" sz="800" dirty="0">
                 <a:solidFill>
-                  <a:srgbClr val="8A8FA3"/>
+                  <a:srgbClr val="B0B0B0"/>
                 </a:solidFill>
                 <a:latin typeface="Calibri" pitchFamily="34" charset="0"/>
                 <a:ea typeface="Calibri" pitchFamily="34" charset="-122"/>
@@ -5121,7 +5121,7 @@
             <a:r>
               <a:rPr lang="en-US" sz="800" dirty="0">
                 <a:solidFill>
-                  <a:srgbClr val="8A8FA3"/>
+                  <a:srgbClr val="B0B0B0"/>
                 </a:solidFill>
                 <a:latin typeface="Calibri" pitchFamily="34" charset="0"/>
                 <a:ea typeface="Calibri" pitchFamily="34" charset="-122"/>
@@ -5199,7 +5199,7 @@
             <a:r>
               <a:rPr lang="en-US" sz="800" dirty="0">
                 <a:solidFill>
-                  <a:srgbClr val="8A8FA3"/>
+                  <a:srgbClr val="B0B0B0"/>
                 </a:solidFill>
                 <a:latin typeface="Calibri" pitchFamily="34" charset="0"/>
                 <a:ea typeface="Calibri" pitchFamily="34" charset="-122"/>
@@ -5216,7 +5216,7 @@
             <a:r>
               <a:rPr lang="en-US" sz="800" dirty="0">
                 <a:solidFill>
-                  <a:srgbClr val="8A8FA3"/>
+                  <a:srgbClr val="B0B0B0"/>
                 </a:solidFill>
                 <a:latin typeface="Calibri" pitchFamily="34" charset="0"/>
                 <a:ea typeface="Calibri" pitchFamily="34" charset="-122"/>
@@ -5294,7 +5294,7 @@
             <a:r>
               <a:rPr lang="en-US" sz="800" dirty="0">
                 <a:solidFill>
-                  <a:srgbClr val="8A8FA3"/>
+                  <a:srgbClr val="B0B0B0"/>
                 </a:solidFill>
                 <a:latin typeface="Calibri" pitchFamily="34" charset="0"/>
                 <a:ea typeface="Calibri" pitchFamily="34" charset="-122"/>
@@ -5311,7 +5311,7 @@
             <a:r>
               <a:rPr lang="en-US" sz="800" dirty="0">
                 <a:solidFill>
-                  <a:srgbClr val="8A8FA3"/>
+                  <a:srgbClr val="B0B0B0"/>
                 </a:solidFill>
                 <a:latin typeface="Calibri" pitchFamily="34" charset="0"/>
                 <a:ea typeface="Calibri" pitchFamily="34" charset="-122"/>
@@ -5411,7 +5411,7 @@
             <a:r>
               <a:rPr lang="en-US" sz="700" dirty="0">
                 <a:solidFill>
-                  <a:srgbClr val="8A8FA3"/>
+                  <a:srgbClr val="B0B0B0"/>
                 </a:solidFill>
                 <a:latin typeface="Calibri" pitchFamily="34" charset="0"/>
                 <a:ea typeface="Calibri" pitchFamily="34" charset="-122"/>
@@ -5521,7 +5521,7 @@
             <a:r>
               <a:rPr lang="en-US" sz="900" dirty="0">
                 <a:solidFill>
-                  <a:srgbClr val="8A8FA3"/>
+                  <a:srgbClr val="B0B0B0"/>
                 </a:solidFill>
                 <a:latin typeface="Calibri" pitchFamily="34" charset="0"/>
                 <a:ea typeface="Calibri" pitchFamily="34" charset="-122"/>
@@ -6718,7 +6718,7 @@
             <a:r>
               <a:rPr lang="en-US" sz="700" dirty="0">
                 <a:solidFill>
-                  <a:srgbClr val="8A8FA3"/>
+                  <a:srgbClr val="B0B0B0"/>
                 </a:solidFill>
                 <a:latin typeface="Calibri" pitchFamily="34" charset="0"/>
                 <a:ea typeface="Calibri" pitchFamily="34" charset="-122"/>
@@ -6735,7 +6735,7 @@
             <a:r>
               <a:rPr lang="en-US" sz="700" dirty="0">
                 <a:solidFill>
-                  <a:srgbClr val="8A8FA3"/>
+                  <a:srgbClr val="B0B0B0"/>
                 </a:solidFill>
                 <a:latin typeface="Calibri" pitchFamily="34" charset="0"/>
                 <a:ea typeface="Calibri" pitchFamily="34" charset="-122"/>
@@ -6840,7 +6840,7 @@
             <a:r>
               <a:rPr lang="en-US" sz="700" dirty="0">
                 <a:solidFill>
-                  <a:srgbClr val="8A8FA3"/>
+                  <a:srgbClr val="B0B0B0"/>
                 </a:solidFill>
                 <a:latin typeface="Calibri" pitchFamily="34" charset="0"/>
                 <a:ea typeface="Calibri" pitchFamily="34" charset="-122"/>
@@ -6857,7 +6857,7 @@
             <a:r>
               <a:rPr lang="en-US" sz="700" dirty="0">
                 <a:solidFill>
-                  <a:srgbClr val="8A8FA3"/>
+                  <a:srgbClr val="B0B0B0"/>
                 </a:solidFill>
                 <a:latin typeface="Calibri" pitchFamily="34" charset="0"/>
                 <a:ea typeface="Calibri" pitchFamily="34" charset="-122"/>
@@ -6962,7 +6962,7 @@
             <a:r>
               <a:rPr lang="en-US" sz="700" dirty="0">
                 <a:solidFill>
-                  <a:srgbClr val="8A8FA3"/>
+                  <a:srgbClr val="B0B0B0"/>
                 </a:solidFill>
                 <a:latin typeface="Calibri" pitchFamily="34" charset="0"/>
                 <a:ea typeface="Calibri" pitchFamily="34" charset="-122"/>
@@ -6979,7 +6979,7 @@
             <a:r>
               <a:rPr lang="en-US" sz="700" dirty="0">
                 <a:solidFill>
-                  <a:srgbClr val="8A8FA3"/>
+                  <a:srgbClr val="B0B0B0"/>
                 </a:solidFill>
                 <a:latin typeface="Calibri" pitchFamily="34" charset="0"/>
                 <a:ea typeface="Calibri" pitchFamily="34" charset="-122"/>
@@ -7084,7 +7084,7 @@
             <a:r>
               <a:rPr lang="en-US" sz="700" dirty="0">
                 <a:solidFill>
-                  <a:srgbClr val="8A8FA3"/>
+                  <a:srgbClr val="B0B0B0"/>
                 </a:solidFill>
                 <a:latin typeface="Calibri" pitchFamily="34" charset="0"/>
                 <a:ea typeface="Calibri" pitchFamily="34" charset="-122"/>
@@ -7101,7 +7101,7 @@
             <a:r>
               <a:rPr lang="en-US" sz="700" dirty="0">
                 <a:solidFill>
-                  <a:srgbClr val="8A8FA3"/>
+                  <a:srgbClr val="B0B0B0"/>
                 </a:solidFill>
                 <a:latin typeface="Calibri" pitchFamily="34" charset="0"/>
                 <a:ea typeface="Calibri" pitchFamily="34" charset="-122"/>
@@ -7206,7 +7206,7 @@
             <a:r>
               <a:rPr lang="en-US" sz="700" dirty="0">
                 <a:solidFill>
-                  <a:srgbClr val="8A8FA3"/>
+                  <a:srgbClr val="B0B0B0"/>
                 </a:solidFill>
                 <a:latin typeface="Calibri" pitchFamily="34" charset="0"/>
                 <a:ea typeface="Calibri" pitchFamily="34" charset="-122"/>
@@ -7223,7 +7223,7 @@
             <a:r>
               <a:rPr lang="en-US" sz="700" dirty="0">
                 <a:solidFill>
-                  <a:srgbClr val="8A8FA3"/>
+                  <a:srgbClr val="B0B0B0"/>
                 </a:solidFill>
                 <a:latin typeface="Calibri" pitchFamily="34" charset="0"/>
                 <a:ea typeface="Calibri" pitchFamily="34" charset="-122"/>
@@ -7323,7 +7323,7 @@
             <a:r>
               <a:rPr lang="en-US" sz="700" dirty="0">
                 <a:solidFill>
-                  <a:srgbClr val="8A8FA3"/>
+                  <a:srgbClr val="B0B0B0"/>
                 </a:solidFill>
                 <a:latin typeface="Calibri" pitchFamily="34" charset="0"/>
                 <a:ea typeface="Calibri" pitchFamily="34" charset="-122"/>

</xml_diff>

<commit_message>
fix: slides MRS→DLI, upload/test scripts, health check rewrite
- slides: MRS Spark references replaced with DLI Spark (matches Terraform)
- upload-contracts-to-obs.sh: new script to trigger OCR pipeline
- test-dataarts-api.sh: new script to test DataService REST endpoints
- health-check.sh: comprehensive — Dify, DWS, Kafka, DataArts, LLM APIs, demo data
- outputs.tf: added web_public_ip, kafka_connect_address, dataarts outputs
</commit_message>
<xml_diff>
--- a/docs/slides-arquitectura.pptx
+++ b/docs/slides-arquitectura.pptx
@@ -1198,6 +1198,10 @@
             </a:outerShdw>
           </a:effectLst>
         </p:spPr>
+        <p:txBody>
+          <a:bodyPr/>
+          <a:p/>
+        </p:txBody>
       </p:sp>
       <p:sp>
         <p:nvSpPr>
@@ -1358,6 +1362,10 @@
             </a:outerShdw>
           </a:effectLst>
         </p:spPr>
+        <p:txBody>
+          <a:bodyPr/>
+          <a:p/>
+        </p:txBody>
       </p:sp>
       <p:sp>
         <p:nvSpPr>
@@ -1501,6 +1509,10 @@
             </a:outerShdw>
           </a:effectLst>
         </p:spPr>
+        <p:txBody>
+          <a:bodyPr/>
+          <a:p/>
+        </p:txBody>
       </p:sp>
       <p:sp>
         <p:nvSpPr>
@@ -1608,6 +1620,10 @@
             </a:outerShdw>
           </a:effectLst>
         </p:spPr>
+        <p:txBody>
+          <a:bodyPr/>
+          <a:p/>
+        </p:txBody>
       </p:sp>
       <p:sp>
         <p:nvSpPr>
@@ -1751,6 +1767,10 @@
             </a:outerShdw>
           </a:effectLst>
         </p:spPr>
+        <p:txBody>
+          <a:bodyPr/>
+          <a:p/>
+        </p:txBody>
       </p:sp>
       <p:sp>
         <p:nvSpPr>
@@ -1914,6 +1934,10 @@
             </a:outerShdw>
           </a:effectLst>
         </p:spPr>
+        <p:txBody>
+          <a:bodyPr/>
+          <a:p/>
+        </p:txBody>
       </p:sp>
       <p:sp>
         <p:nvSpPr>
@@ -1948,7 +1972,7 @@
                 <a:ea typeface="Calibri" pitchFamily="34" charset="-122"/>
                 <a:cs typeface="Calibri" pitchFamily="34" charset="-120"/>
               </a:rPr>
-              <a:t>MRS (Spark)</a:t>
+              <a:t>DLI Spark</a:t>
             </a:r>
             <a:endParaRPr lang="en-US" sz="900" dirty="0"/>
           </a:p>
@@ -2057,6 +2081,10 @@
             </a:outerShdw>
           </a:effectLst>
         </p:spPr>
+        <p:txBody>
+          <a:bodyPr/>
+          <a:p/>
+        </p:txBody>
       </p:sp>
       <p:sp>
         <p:nvSpPr>
@@ -2164,6 +2192,10 @@
             </a:outerShdw>
           </a:effectLst>
         </p:spPr>
+        <p:txBody>
+          <a:bodyPr/>
+          <a:p/>
+        </p:txBody>
       </p:sp>
       <p:sp>
         <p:nvSpPr>
@@ -2307,6 +2339,10 @@
             </a:outerShdw>
           </a:effectLst>
         </p:spPr>
+        <p:txBody>
+          <a:bodyPr/>
+          <a:p/>
+        </p:txBody>
       </p:sp>
       <p:sp>
         <p:nvSpPr>
@@ -2453,6 +2489,10 @@
             </a:outerShdw>
           </a:effectLst>
         </p:spPr>
+        <p:txBody>
+          <a:bodyPr/>
+          <a:p/>
+        </p:txBody>
       </p:sp>
       <p:sp>
         <p:nvSpPr>
@@ -2596,6 +2636,10 @@
             </a:outerShdw>
           </a:effectLst>
         </p:spPr>
+        <p:txBody>
+          <a:bodyPr/>
+          <a:p/>
+        </p:txBody>
       </p:sp>
       <p:sp>
         <p:nvSpPr>
@@ -2720,6 +2764,10 @@
             </a:outerShdw>
           </a:effectLst>
         </p:spPr>
+        <p:txBody>
+          <a:bodyPr/>
+          <a:p/>
+        </p:txBody>
       </p:sp>
       <p:sp>
         <p:nvSpPr>
@@ -2863,6 +2911,10 @@
             </a:outerShdw>
           </a:effectLst>
         </p:spPr>
+        <p:txBody>
+          <a:bodyPr/>
+          <a:p/>
+        </p:txBody>
       </p:sp>
       <p:sp>
         <p:nvSpPr>
@@ -3009,6 +3061,10 @@
             </a:outerShdw>
           </a:effectLst>
         </p:spPr>
+        <p:txBody>
+          <a:bodyPr/>
+          <a:p/>
+        </p:txBody>
       </p:sp>
       <p:sp>
         <p:nvSpPr>
@@ -3116,6 +3172,10 @@
             </a:outerShdw>
           </a:effectLst>
         </p:spPr>
+        <p:txBody>
+          <a:bodyPr/>
+          <a:p/>
+        </p:txBody>
       </p:sp>
       <p:sp>
         <p:nvSpPr>
@@ -3216,6 +3276,10 @@
           </a:solidFill>
           <a:ln/>
         </p:spPr>
+        <p:txBody>
+          <a:bodyPr/>
+          <a:p/>
+        </p:txBody>
       </p:sp>
       <p:sp>
         <p:nvSpPr>
@@ -3901,6 +3965,10 @@
             </a:outerShdw>
           </a:effectLst>
         </p:spPr>
+        <p:txBody>
+          <a:bodyPr/>
+          <a:p/>
+        </p:txBody>
       </p:sp>
       <p:sp>
         <p:nvSpPr>
@@ -4039,6 +4107,10 @@
             </a:outerShdw>
           </a:effectLst>
         </p:spPr>
+        <p:txBody>
+          <a:bodyPr/>
+          <a:p/>
+        </p:txBody>
       </p:sp>
       <p:sp>
         <p:nvSpPr>
@@ -4177,6 +4249,10 @@
             </a:outerShdw>
           </a:effectLst>
         </p:spPr>
+        <p:txBody>
+          <a:bodyPr/>
+          <a:p/>
+        </p:txBody>
       </p:sp>
       <p:sp>
         <p:nvSpPr>
@@ -4315,6 +4391,10 @@
             </a:outerShdw>
           </a:effectLst>
         </p:spPr>
+        <p:txBody>
+          <a:bodyPr/>
+          <a:p/>
+        </p:txBody>
       </p:sp>
       <p:sp>
         <p:nvSpPr>
@@ -4349,7 +4429,7 @@
                 <a:ea typeface="Calibri" pitchFamily="34" charset="-122"/>
                 <a:cs typeface="Calibri" pitchFamily="34" charset="-120"/>
               </a:rPr>
-              <a:t>MRS Spark</a:t>
+              <a:t>DLI Spark</a:t>
             </a:r>
             <a:endParaRPr lang="en-US" sz="900" dirty="0"/>
           </a:p>
@@ -4453,6 +4533,10 @@
             </a:outerShdw>
           </a:effectLst>
         </p:spPr>
+        <p:txBody>
+          <a:bodyPr/>
+          <a:p/>
+        </p:txBody>
       </p:sp>
       <p:sp>
         <p:nvSpPr>
@@ -4555,6 +4639,10 @@
             </a:outerShdw>
           </a:effectLst>
         </p:spPr>
+        <p:txBody>
+          <a:bodyPr/>
+          <a:p/>
+        </p:txBody>
       </p:sp>
       <p:sp>
         <p:nvSpPr>
@@ -4662,6 +4750,10 @@
             </a:outerShdw>
           </a:effectLst>
         </p:spPr>
+        <p:txBody>
+          <a:bodyPr/>
+          <a:p/>
+        </p:txBody>
       </p:sp>
       <p:sp>
         <p:nvSpPr>
@@ -4769,6 +4861,10 @@
             </a:outerShdw>
           </a:effectLst>
         </p:spPr>
+        <p:txBody>
+          <a:bodyPr/>
+          <a:p/>
+        </p:txBody>
       </p:sp>
       <p:sp>
         <p:nvSpPr>
@@ -5344,6 +5440,10 @@
           </a:solidFill>
           <a:ln/>
         </p:spPr>
+        <p:txBody>
+          <a:bodyPr/>
+          <a:p/>
+        </p:txBody>
       </p:sp>
       <p:sp>
         <p:nvSpPr>
@@ -5561,6 +5661,10 @@
             </a:outerShdw>
           </a:effectLst>
         </p:spPr>
+        <p:txBody>
+          <a:bodyPr/>
+          <a:p/>
+        </p:txBody>
       </p:sp>
       <p:sp>
         <p:nvSpPr>
@@ -5682,6 +5786,10 @@
             </a:outerShdw>
           </a:effectLst>
         </p:spPr>
+        <p:txBody>
+          <a:bodyPr/>
+          <a:p/>
+        </p:txBody>
       </p:sp>
       <p:sp>
         <p:nvSpPr>
@@ -5803,6 +5911,10 @@
             </a:outerShdw>
           </a:effectLst>
         </p:spPr>
+        <p:txBody>
+          <a:bodyPr/>
+          <a:p/>
+        </p:txBody>
       </p:sp>
       <p:sp>
         <p:nvSpPr>
@@ -5924,6 +6036,10 @@
             </a:outerShdw>
           </a:effectLst>
         </p:spPr>
+        <p:txBody>
+          <a:bodyPr/>
+          <a:p/>
+        </p:txBody>
       </p:sp>
       <p:sp>
         <p:nvSpPr>
@@ -6045,6 +6161,10 @@
             </a:outerShdw>
           </a:effectLst>
         </p:spPr>
+        <p:txBody>
+          <a:bodyPr/>
+          <a:p/>
+        </p:txBody>
       </p:sp>
       <p:sp>
         <p:nvSpPr>
@@ -6166,6 +6286,10 @@
             </a:outerShdw>
           </a:effectLst>
         </p:spPr>
+        <p:txBody>
+          <a:bodyPr/>
+          <a:p/>
+        </p:txBody>
       </p:sp>
       <p:sp>
         <p:nvSpPr>
@@ -6287,6 +6411,10 @@
             </a:outerShdw>
           </a:effectLst>
         </p:spPr>
+        <p:txBody>
+          <a:bodyPr/>
+          <a:p/>
+        </p:txBody>
       </p:sp>
       <p:sp>
         <p:nvSpPr>
@@ -6408,6 +6536,10 @@
             </a:outerShdw>
           </a:effectLst>
         </p:spPr>
+        <p:txBody>
+          <a:bodyPr/>
+          <a:p/>
+        </p:txBody>
       </p:sp>
       <p:sp>
         <p:nvSpPr>
@@ -6529,6 +6661,10 @@
             </a:outerShdw>
           </a:effectLst>
         </p:spPr>
+        <p:txBody>
+          <a:bodyPr/>
+          <a:p/>
+        </p:txBody>
       </p:sp>
       <p:sp>
         <p:nvSpPr>
@@ -6651,6 +6787,10 @@
             <a:prstDash val="solid"/>
           </a:ln>
         </p:spPr>
+        <p:txBody>
+          <a:bodyPr/>
+          <a:p/>
+        </p:txBody>
       </p:sp>
       <p:sp>
         <p:nvSpPr>
@@ -6773,6 +6913,10 @@
             <a:prstDash val="solid"/>
           </a:ln>
         </p:spPr>
+        <p:txBody>
+          <a:bodyPr/>
+          <a:p/>
+        </p:txBody>
       </p:sp>
       <p:sp>
         <p:nvSpPr>
@@ -6895,6 +7039,10 @@
             <a:prstDash val="solid"/>
           </a:ln>
         </p:spPr>
+        <p:txBody>
+          <a:bodyPr/>
+          <a:p/>
+        </p:txBody>
       </p:sp>
       <p:sp>
         <p:nvSpPr>
@@ -7017,6 +7165,10 @@
             <a:prstDash val="solid"/>
           </a:ln>
         </p:spPr>
+        <p:txBody>
+          <a:bodyPr/>
+          <a:p/>
+        </p:txBody>
       </p:sp>
       <p:sp>
         <p:nvSpPr>
@@ -7139,6 +7291,10 @@
             <a:prstDash val="solid"/>
           </a:ln>
         </p:spPr>
+        <p:txBody>
+          <a:bodyPr/>
+          <a:p/>
+        </p:txBody>
       </p:sp>
       <p:sp>
         <p:nvSpPr>
@@ -7256,6 +7412,10 @@
           </a:solidFill>
           <a:ln/>
         </p:spPr>
+        <p:txBody>
+          <a:bodyPr/>
+          <a:p/>
+        </p:txBody>
       </p:sp>
       <p:sp>
         <p:nvSpPr>

</xml_diff>

<commit_message>
fix: remove DMS Kafka from slides + drawio diagrams
- slides-arquitectura.pptx: removed DMS Kafka from Slide 1 and Slide 3
- architecture.drawio: removed Kafka cell and edges
- All docs now clean: zero DMS/Kafka/MRS references
</commit_message>
<xml_diff>
--- a/docs/slides-arquitectura.pptx
+++ b/docs/slides-arquitectura.pptx
@@ -1538,17 +1538,6 @@
             <a:pPr algn="ctr" indent="0" marL="0">
               <a:buNone/>
             </a:pPr>
-            <a:r>
-              <a:rPr lang="en-US" sz="900" b="1" dirty="0">
-                <a:solidFill>
-                  <a:srgbClr val="FFFFFF"/>
-                </a:solidFill>
-                <a:latin typeface="Calibri" pitchFamily="34" charset="0"/>
-                <a:ea typeface="Calibri" pitchFamily="34" charset="-122"/>
-                <a:cs typeface="Calibri" pitchFamily="34" charset="-120"/>
-              </a:rPr>
-              <a:t>DMS</a:t>
-            </a:r>
             <a:endParaRPr lang="en-US" sz="900" dirty="0"/>
           </a:p>
         </p:txBody>
@@ -1586,7 +1575,7 @@
                 <a:ea typeface="Calibri" pitchFamily="34" charset="-122"/>
                 <a:cs typeface="Calibri" pitchFamily="34" charset="-120"/>
               </a:rPr>
-              <a:t>Kafka</a:t>
+              <a:t/>
             </a:r>
             <a:endParaRPr lang="en-US" sz="700" dirty="0"/>
           </a:p>
@@ -5940,6 +5929,12 @@
             <a:pPr algn="ctr" indent="0" marL="0">
               <a:buNone/>
             </a:pPr>
+            <a:endParaRPr lang="en-US" sz="900" dirty="0"/>
+          </a:p>
+          <a:p>
+            <a:pPr algn="ctr" indent="0" marL="0">
+              <a:buNone/>
+            </a:pPr>
             <a:r>
               <a:rPr lang="en-US" sz="900" dirty="0">
                 <a:solidFill>
@@ -5949,24 +5944,7 @@
                 <a:ea typeface="Calibri" pitchFamily="34" charset="-122"/>
                 <a:cs typeface="Calibri" pitchFamily="34" charset="-120"/>
               </a:rPr>
-              <a:t>DMS</a:t>
-            </a:r>
-            <a:endParaRPr lang="en-US" sz="900" dirty="0"/>
-          </a:p>
-          <a:p>
-            <a:pPr algn="ctr" indent="0" marL="0">
-              <a:buNone/>
-            </a:pPr>
-            <a:r>
-              <a:rPr lang="en-US" sz="900" dirty="0">
-                <a:solidFill>
-                  <a:srgbClr val="FFFFFF"/>
-                </a:solidFill>
-                <a:latin typeface="Calibri" pitchFamily="34" charset="0"/>
-                <a:ea typeface="Calibri" pitchFamily="34" charset="-122"/>
-                <a:cs typeface="Calibri" pitchFamily="34" charset="-120"/>
-              </a:rPr>
-              <a:t>Kafka</a:t>
+              <a:t/>
             </a:r>
             <a:endParaRPr lang="en-US" sz="900" dirty="0"/>
           </a:p>

</xml_diff>

<commit_message>
Align AYCO documentation and presentation artifacts
</commit_message>
<xml_diff>
--- a/docs/slides-arquitectura.pptx
+++ b/docs/slides-arquitectura.pptx
@@ -3342,7 +3342,7 @@
                 <a:ea typeface="Calibri" pitchFamily="34" charset="-122"/>
                 <a:cs typeface="Calibri" pitchFamily="34" charset="-120"/>
               </a:rPr>
-              <a:t>CFW Firewall</a:t>
+              <a:t>Security Groups</a:t>
             </a:r>
             <a:endParaRPr lang="en-US" sz="700" dirty="0"/>
           </a:p>
@@ -3381,7 +3381,7 @@
                 <a:ea typeface="Calibri" pitchFamily="34" charset="-122"/>
                 <a:cs typeface="Calibri" pitchFamily="34" charset="-120"/>
               </a:rPr>
-              <a:t>WAF</a:t>
+              <a:t>VPC Isolation</a:t>
             </a:r>
             <a:endParaRPr lang="en-US" sz="700" dirty="0"/>
           </a:p>
@@ -3420,7 +3420,7 @@
                 <a:ea typeface="Calibri" pitchFamily="34" charset="-122"/>
                 <a:cs typeface="Calibri" pitchFamily="34" charset="-120"/>
               </a:rPr>
-              <a:t>IAM Condicional</a:t>
+              <a:t>IAM Roles</a:t>
             </a:r>
             <a:endParaRPr lang="en-US" sz="700" dirty="0"/>
           </a:p>
@@ -3498,7 +3498,7 @@
                 <a:ea typeface="Calibri" pitchFamily="34" charset="-122"/>
                 <a:cs typeface="Calibri" pitchFamily="34" charset="-120"/>
               </a:rPr>
-              <a:t>CNBV Compliance</a:t>
+              <a:t>Controles CNBV</a:t>
             </a:r>
             <a:endParaRPr lang="en-US" sz="700" dirty="0"/>
           </a:p>
@@ -4888,7 +4888,7 @@
                 <a:ea typeface="Calibri" pitchFamily="34" charset="-122"/>
                 <a:cs typeface="Calibri" pitchFamily="34" charset="-120"/>
               </a:rPr>
-              <a:t>CNBV Compliance</a:t>
+              <a:t>Controles CNBV</a:t>
             </a:r>
             <a:endParaRPr lang="en-US" sz="1000" dirty="0"/>
           </a:p>
@@ -5346,7 +5346,7 @@
                 <a:ea typeface="Calibri" pitchFamily="34" charset="-122"/>
                 <a:cs typeface="Calibri" pitchFamily="34" charset="-120"/>
               </a:rPr>
-              <a:t>99.98%</a:t>
+              <a:t>3</a:t>
             </a:r>
             <a:endParaRPr lang="en-US" sz="1800" dirty="0"/>
           </a:p>
@@ -5385,7 +5385,7 @@
                 <a:ea typeface="Calibri" pitchFamily="34" charset="-122"/>
                 <a:cs typeface="Calibri" pitchFamily="34" charset="-120"/>
               </a:rPr>
-              <a:t>disponibilidad</a:t>
+              <a:t>demos</a:t>
             </a:r>
             <a:endParaRPr lang="en-US" sz="800" dirty="0"/>
           </a:p>
@@ -5402,7 +5402,7 @@
                 <a:ea typeface="Calibri" pitchFamily="34" charset="-122"/>
                 <a:cs typeface="Calibri" pitchFamily="34" charset="-120"/>
               </a:rPr>
-              <a:t>plataforma</a:t>
+              <a:t>integrados</a:t>
             </a:r>
             <a:endParaRPr lang="en-US" sz="800" dirty="0"/>
           </a:p>
@@ -5467,7 +5467,7 @@
                 <a:ea typeface="Calibri" pitchFamily="34" charset="-122"/>
                 <a:cs typeface="Calibri" pitchFamily="34" charset="-120"/>
               </a:rPr>
-              <a:t>CFW · WAF · IAM · KMS  |  Cumplimiento CNBV · Banxico · Ley Fintech (AML/KYC)</a:t>
+              <a:t>Security Groups · IAM · KMS · OBS Encryption  |  Controles alineados a CNBV/Banxico (AML/KYC)</a:t>
             </a:r>
             <a:endParaRPr lang="en-US" sz="700" dirty="0"/>
           </a:p>
@@ -7428,7 +7428,7 @@
                 <a:ea typeface="Calibri" pitchFamily="34" charset="-122"/>
                 <a:cs typeface="Calibri" pitchFamily="34" charset="-120"/>
               </a:rPr>
-              <a:t>De revisar contratos en silos → chatbot que responde en segundos sobre todo tu portafolio. DeepSeek + Dify = abogado AI 24/7.</a:t>
+              <a:t>De revisar contratos en silos → chatbot que responde en segundos sobre todo tu portafolio. DeepSeek + Dify = asistente contractual 24/7.</a:t>
             </a:r>
             <a:endParaRPr lang="en-US" sz="900" dirty="0"/>
           </a:p>

</xml_diff>

<commit_message>
docs: align slides and docs with current state (20 contracts, 3 OBS buckets)\n\n- architecture.md: OBS diagram ×5→×3, add 20 seed contracts, total exposure\n- demo-script.md: 3→20 contracts in all 11 references, DWS expected outputs\n- slides-arquitectura.pptx: 3 SAR→20 alertas, 3 Contratos→20 Contratos, OBS
</commit_message>
<xml_diff>
--- a/docs/slides-arquitectura.pptx
+++ b/docs/slides-arquitectura.pptx
@@ -5243,15 +5243,7 @@
               <a:buNone/>
             </a:pPr>
             <a:r>
-              <a:rPr lang="en-US" sz="1800" b="1" dirty="0">
-                <a:solidFill>
-                  <a:srgbClr val="C7000B"/>
-                </a:solidFill>
-                <a:latin typeface="Calibri" pitchFamily="34" charset="0"/>
-                <a:ea typeface="Calibri" pitchFamily="34" charset="-122"/>
-                <a:cs typeface="Calibri" pitchFamily="34" charset="-120"/>
-              </a:rPr>
-              <a:t>3 SAR</a:t>
+              <a:t>20 alertas</a:t>
             </a:r>
             <a:endParaRPr lang="en-US" sz="1800" dirty="0"/>
           </a:p>
@@ -5697,15 +5689,7 @@
               <a:buNone/>
             </a:pPr>
             <a:r>
-              <a:rPr lang="en-US" sz="900" dirty="0">
-                <a:solidFill>
-                  <a:srgbClr val="FFFFFF"/>
-                </a:solidFill>
-                <a:latin typeface="Calibri" pitchFamily="34" charset="0"/>
-                <a:ea typeface="Calibri" pitchFamily="34" charset="-122"/>
-                <a:cs typeface="Calibri" pitchFamily="34" charset="-120"/>
-              </a:rPr>
-              <a:t>3 Contratos → OBS</a:t>
+              <a:t>20 Contratos → OBS</a:t>
             </a:r>
             <a:endParaRPr lang="en-US" sz="900" dirty="0"/>
           </a:p>

</xml_diff>

<commit_message>
Align demo artifacts with 20-contract story
</commit_message>
<xml_diff>
--- a/docs/slides-arquitectura.pptx
+++ b/docs/slides-arquitectura.pptx
@@ -5749,7 +5749,7 @@
               </a:defRPr>
             </a:pPr>
             <a:r>
-              <a:t>200ms</a:t>
+              <a:t>Dry run</a:t>
             </a:r>
           </a:p>
         </p:txBody>
@@ -5785,7 +5785,7 @@
               </a:defRPr>
             </a:pPr>
             <a:r>
-              <a:t>avg latency</a:t>
+              <a:t>latency</a:t>
             </a:r>
           </a:p>
         </p:txBody>
@@ -5900,7 +5900,7 @@
               </a:defRPr>
             </a:pPr>
             <a:r>
-              <a:t>▸  VPC Isolation — 10.1.0.0/16 private subnets</a:t>
+              <a:t>▸  VPC Isolation — 172.16.0.0/16 private subnets</a:t>
             </a:r>
           </a:p>
         </p:txBody>
@@ -6080,7 +6080,7 @@
               </a:defRPr>
             </a:pPr>
             <a:r>
-              <a:t>▸  CNBV compliance — AML, KYC, audit trail</a:t>
+              <a:t>▸  CNBV alignment — AML, KYC, audit trail</a:t>
             </a:r>
           </a:p>
         </p:txBody>

</xml_diff>